<commit_message>
Update Slide 12 to contain clean references instead of URLs
</commit_message>
<xml_diff>
--- a/frontend/public/downloads/FacilityOS_12_Slide_Presentation.pptx
+++ b/frontend/public/downloads/FacilityOS_12_Slide_Presentation.pptx
@@ -4229,7 +4229,7 @@
               </a:defRPr>
             </a:pPr>
             <a:r>
-              <a:t>11. Expected Outcomes &amp; Presentation Links</a:t>
+              <a:t>11. Expected Outcomes &amp; Project References</a:t>
             </a:r>
           </a:p>
         </p:txBody>
@@ -4242,8 +4242,8 @@
         </p:nvSpPr>
         <p:spPr>
           <a:xfrm>
-            <a:off x="1371600" y="1554480"/>
-            <a:ext cx="9448495" cy="4754880"/>
+            <a:off x="731520" y="1554480"/>
+            <a:ext cx="5120640" cy="4754880"/>
           </a:xfrm>
           <a:prstGeom prst="roundRect">
             <a:avLst/>
@@ -4286,7 +4286,7 @@
               </a:defRPr>
             </a:pPr>
             <a:r>
-              <a:t>Project Outcomes &amp; Deliverables Summary</a:t>
+              <a:t>Project Outcomes &amp; Deliverables</a:t>
             </a:r>
           </a:p>
           <a:p>
@@ -4361,37 +4361,124 @@
               </a:defRPr>
             </a:pPr>
             <a:r>
-              <a:t>• 🌐 Live Production Web App:  https://facilityos-brown.vercel.app</a:t>
-            </a:r>
-          </a:p>
-          <a:p>
-            <a:pPr>
-              <a:spcAft>
-                <a:spcPts val="500"/>
-              </a:spcAft>
-              <a:defRPr sz="1200">
-                <a:solidFill>
-                  <a:srgbClr val="CBD5F5"/>
-                </a:solidFill>
-              </a:defRPr>
-            </a:pPr>
-            <a:r>
-              <a:t>• 🐙 GitHub Source Code:  https://github.com/Invarsoft/facilityos-pro</a:t>
-            </a:r>
-          </a:p>
-          <a:p>
-            <a:pPr>
-              <a:spcAft>
-                <a:spcPts val="500"/>
-              </a:spcAft>
-              <a:defRPr sz="1200">
-                <a:solidFill>
-                  <a:srgbClr val="CBD5F5"/>
-                </a:solidFill>
-              </a:defRPr>
-            </a:pPr>
-            <a:r>
-              <a:t>• 📊 Direct Download Links:  /downloads/FacilityOS_12_Slide_Presentation.pptx</a:t>
+              <a:t>• Scalable multi-tenant campus deployment architecture.</a:t>
+            </a:r>
+          </a:p>
+        </p:txBody>
+      </p:sp>
+      <p:sp>
+        <p:nvSpPr>
+          <p:cNvPr id="4" name="Rounded Rectangle 3"/>
+          <p:cNvSpPr/>
+          <p:nvPr/>
+        </p:nvSpPr>
+        <p:spPr>
+          <a:xfrm>
+            <a:off x="6217920" y="1554480"/>
+            <a:ext cx="5120640" cy="4754880"/>
+          </a:xfrm>
+          <a:prstGeom prst="roundRect">
+            <a:avLst/>
+          </a:prstGeom>
+          <a:solidFill>
+            <a:srgbClr val="262C52"/>
+          </a:solidFill>
+          <a:ln>
+            <a:solidFill>
+              <a:srgbClr val="384073"/>
+            </a:solidFill>
+          </a:ln>
+        </p:spPr>
+        <p:style>
+          <a:lnRef idx="1">
+            <a:schemeClr val="accent1"/>
+          </a:lnRef>
+          <a:fillRef idx="3">
+            <a:schemeClr val="accent1"/>
+          </a:fillRef>
+          <a:effectRef idx="2">
+            <a:schemeClr val="accent1"/>
+          </a:effectRef>
+          <a:fontRef idx="minor">
+            <a:schemeClr val="lt1"/>
+          </a:fontRef>
+        </p:style>
+        <p:txBody>
+          <a:bodyPr rtlCol="0" anchor="ctr" wrap="square" lIns="228600" tIns="228600" rIns="228600" bIns="228600"/>
+          <a:lstStyle/>
+          <a:p>
+            <a:pPr algn="ctr">
+              <a:spcAft>
+                <a:spcPts val="800"/>
+              </a:spcAft>
+              <a:defRPr sz="1600" b="1">
+                <a:solidFill>
+                  <a:srgbClr val="4DE0B4"/>
+                </a:solidFill>
+              </a:defRPr>
+            </a:pPr>
+            <a:r>
+              <a:t>Academic &amp; Technical References</a:t>
+            </a:r>
+          </a:p>
+          <a:p>
+            <a:pPr>
+              <a:spcAft>
+                <a:spcPts val="500"/>
+              </a:spcAft>
+              <a:defRPr sz="1200">
+                <a:solidFill>
+                  <a:srgbClr val="CBD5F5"/>
+                </a:solidFill>
+              </a:defRPr>
+            </a:pPr>
+            <a:r>
+              <a:t>• Reference 1: FacilityOS Multi-Tenant Architecture &amp; Service Level Agreement (SLA) Enforcement Framework.</a:t>
+            </a:r>
+          </a:p>
+          <a:p>
+            <a:pPr>
+              <a:spcAft>
+                <a:spcPts val="500"/>
+              </a:spcAft>
+              <a:defRPr sz="1200">
+                <a:solidFill>
+                  <a:srgbClr val="CBD5F5"/>
+                </a:solidFill>
+              </a:defRPr>
+            </a:pPr>
+            <a:r>
+              <a:t>• Reference 2: Next.js 15 App Router Architecture &amp; Serverless Deployment Standards.</a:t>
+            </a:r>
+          </a:p>
+          <a:p>
+            <a:pPr>
+              <a:spcAft>
+                <a:spcPts val="500"/>
+              </a:spcAft>
+              <a:defRPr sz="1200">
+                <a:solidFill>
+                  <a:srgbClr val="CBD5F5"/>
+                </a:solidFill>
+              </a:defRPr>
+            </a:pPr>
+            <a:r>
+              <a:t>• Reference 3: Woxsen University AIML Department Capstone Project Technical Benchmark.</a:t>
+            </a:r>
+          </a:p>
+          <a:p>
+            <a:pPr>
+              <a:spcAft>
+                <a:spcPts val="500"/>
+              </a:spcAft>
+              <a:defRPr sz="1200">
+                <a:solidFill>
+                  <a:srgbClr val="CBD5F5"/>
+                </a:solidFill>
+              </a:defRPr>
+            </a:pPr>
+            <a:r>
+              <a:t>• Reference 4: ISO 55001 Asset Management &amp; Facility Operations Standards.</a:t>
             </a:r>
           </a:p>
         </p:txBody>

</xml_diff>